<commit_message>
bringing-the-model-home: the speaker photo was missing since the restructure
The path was rebuilt from __file__ as .parent.parent, which resolved to talks/
once the script moved into talks/<name>/. ROOT was corrected in that move; this
line was not. The portrait silently fell back to initials -- which looks like a
deliberate design choice, so nothing flagged it through several rebuilds.

Co-Authored-By: Claude Opus 5 (1M context) <noreply@anthropic.com>
</commit_message>
<xml_diff>
--- a/talks/bringing-the-model-home/pitch/BringingTheModelHome.pptx
+++ b/talks/bringing-the-model-home/pitch/BringingTheModelHome.pptx
@@ -3250,7 +3250,7 @@
       </p:sp>
       <p:sp>
         <p:nvSpPr>
-          <p:cNvPr id="5" name="Rectangle 4"/>
+          <p:cNvPr id="5" name="deckkit-rule"/>
           <p:cNvSpPr/>
           <p:nvPr/>
         </p:nvSpPr>
@@ -3586,7 +3586,7 @@
       </p:sp>
       <p:sp>
         <p:nvSpPr>
-          <p:cNvPr id="5" name="Rectangle 4"/>
+          <p:cNvPr id="5" name="deckkit-rule"/>
           <p:cNvSpPr/>
           <p:nvPr/>
         </p:nvSpPr>
@@ -4282,7 +4282,7 @@
       </p:sp>
       <p:sp>
         <p:nvSpPr>
-          <p:cNvPr id="5" name="Rectangle 4"/>
+          <p:cNvPr id="5" name="deckkit-rule"/>
           <p:cNvSpPr/>
           <p:nvPr/>
         </p:nvSpPr>
@@ -6133,7 +6133,7 @@
       </p:sp>
       <p:sp>
         <p:nvSpPr>
-          <p:cNvPr id="5" name="Rectangle 4"/>
+          <p:cNvPr id="5" name="deckkit-rule"/>
           <p:cNvSpPr/>
           <p:nvPr/>
         </p:nvSpPr>
@@ -7995,7 +7995,7 @@
       </p:sp>
       <p:sp>
         <p:nvSpPr>
-          <p:cNvPr id="5" name="Rectangle 4"/>
+          <p:cNvPr id="5" name="deckkit-rule"/>
           <p:cNvSpPr/>
           <p:nvPr/>
         </p:nvSpPr>
@@ -8823,7 +8823,7 @@
       </p:sp>
       <p:sp>
         <p:nvSpPr>
-          <p:cNvPr id="6" name="Rectangle 5"/>
+          <p:cNvPr id="6" name="deckkit-rule"/>
           <p:cNvSpPr/>
           <p:nvPr/>
         </p:nvSpPr>
@@ -9753,7 +9753,7 @@
       </p:sp>
       <p:sp>
         <p:nvSpPr>
-          <p:cNvPr id="5" name="Rectangle 4"/>
+          <p:cNvPr id="5" name="deckkit-rule"/>
           <p:cNvSpPr/>
           <p:nvPr/>
         </p:nvSpPr>
@@ -10590,7 +10590,7 @@
       </p:sp>
       <p:sp>
         <p:nvSpPr>
-          <p:cNvPr id="5" name="Rectangle 4"/>
+          <p:cNvPr id="5" name="deckkit-rule"/>
           <p:cNvSpPr/>
           <p:nvPr/>
         </p:nvSpPr>
@@ -11022,7 +11022,7 @@
       </p:sp>
       <p:sp>
         <p:nvSpPr>
-          <p:cNvPr id="5" name="Rectangle 4"/>
+          <p:cNvPr id="5" name="deckkit-rule"/>
           <p:cNvSpPr/>
           <p:nvPr/>
         </p:nvSpPr>
@@ -11064,12 +11064,20 @@
           </a:p>
         </p:txBody>
       </p:sp>
-      <p:sp>
-        <p:nvSpPr>
-          <p:cNvPr id="6" name="Oval 5"/>
-          <p:cNvSpPr/>
-          <p:nvPr/>
-        </p:nvSpPr>
+      <p:pic>
+        <p:nvPicPr>
+          <p:cNvPr id="6" name="Picture 5" descr="sorour.jpg"/>
+          <p:cNvPicPr>
+            <a:picLocks noChangeAspect="1"/>
+          </p:cNvPicPr>
+          <p:nvPr/>
+        </p:nvPicPr>
+        <p:blipFill>
+          <a:blip r:embed="rId2"/>
+          <a:stretch>
+            <a:fillRect/>
+          </a:stretch>
+        </p:blipFill>
         <p:spPr>
           <a:xfrm>
             <a:off x="8503920" y="2286000"/>
@@ -11078,47 +11086,13 @@
           <a:prstGeom prst="ellipse">
             <a:avLst/>
           </a:prstGeom>
-          <a:solidFill>
-            <a:srgbClr val="1C2230"/>
-          </a:solidFill>
           <a:ln w="25400">
             <a:solidFill>
               <a:srgbClr val="4FD1C5"/>
             </a:solidFill>
           </a:ln>
-          <a:effectLst/>
-        </p:spPr>
-        <p:style>
-          <a:lnRef idx="1">
-            <a:schemeClr val="accent1"/>
-          </a:lnRef>
-          <a:fillRef idx="3">
-            <a:schemeClr val="accent1"/>
-          </a:fillRef>
-          <a:effectRef idx="2">
-            <a:schemeClr val="accent1"/>
-          </a:effectRef>
-          <a:fontRef idx="minor">
-            <a:schemeClr val="lt1"/>
-          </a:fontRef>
-        </p:style>
-        <p:txBody>
-          <a:bodyPr rtlCol="0" anchor="ctr"/>
-          <a:lstStyle/>
-          <a:p>
-            <a:pPr algn="ctr"/>
-            <a:r>
-              <a:rPr sz="5200" b="1">
-                <a:solidFill>
-                  <a:srgbClr val="4FD1C5"/>
-                </a:solidFill>
-                <a:latin typeface="Menlo"/>
-              </a:rPr>
-              <a:t>MS</a:t>
-            </a:r>
-          </a:p>
-        </p:txBody>
-      </p:sp>
+        </p:spPr>
+      </p:pic>
       <p:sp>
         <p:nvSpPr>
           <p:cNvPr id="7" name="TextBox 6"/>
@@ -11822,7 +11796,7 @@
       </p:sp>
       <p:sp>
         <p:nvSpPr>
-          <p:cNvPr id="5" name="Rectangle 4"/>
+          <p:cNvPr id="5" name="deckkit-rule"/>
           <p:cNvSpPr/>
           <p:nvPr/>
         </p:nvSpPr>
@@ -12430,7 +12404,7 @@
       </p:sp>
       <p:sp>
         <p:nvSpPr>
-          <p:cNvPr id="5" name="Rectangle 4"/>
+          <p:cNvPr id="5" name="deckkit-rule"/>
           <p:cNvSpPr/>
           <p:nvPr/>
         </p:nvSpPr>
@@ -14014,7 +13988,7 @@
       </p:sp>
       <p:sp>
         <p:nvSpPr>
-          <p:cNvPr id="5" name="Rectangle 4"/>
+          <p:cNvPr id="5" name="deckkit-rule"/>
           <p:cNvSpPr/>
           <p:nvPr/>
         </p:nvSpPr>
@@ -15888,7 +15862,7 @@
       </p:sp>
       <p:sp>
         <p:nvSpPr>
-          <p:cNvPr id="6" name="Rectangle 5"/>
+          <p:cNvPr id="6" name="deckkit-rule"/>
           <p:cNvSpPr/>
           <p:nvPr/>
         </p:nvSpPr>
@@ -16584,7 +16558,7 @@
       </p:sp>
       <p:sp>
         <p:nvSpPr>
-          <p:cNvPr id="5" name="Rectangle 4"/>
+          <p:cNvPr id="5" name="deckkit-rule"/>
           <p:cNvSpPr/>
           <p:nvPr/>
         </p:nvSpPr>
@@ -17888,7 +17862,7 @@
       </p:sp>
       <p:sp>
         <p:nvSpPr>
-          <p:cNvPr id="5" name="Rectangle 4"/>
+          <p:cNvPr id="5" name="deckkit-rule"/>
           <p:cNvSpPr/>
           <p:nvPr/>
         </p:nvSpPr>
@@ -18924,7 +18898,7 @@
       </p:sp>
       <p:sp>
         <p:nvSpPr>
-          <p:cNvPr id="5" name="Rectangle 4"/>
+          <p:cNvPr id="5" name="deckkit-rule"/>
           <p:cNvSpPr/>
           <p:nvPr/>
         </p:nvSpPr>

</xml_diff>